<commit_message>
docs(presentation): update 10-slide deck with live GitHub Pages deployment and reviewer CTA
</commit_message>
<xml_diff>
--- a/presentation/GCC_Compass_Product_Presentation.pptx
+++ b/presentation/GCC_Compass_Product_Presentation.pptx
@@ -3683,8 +3683,8 @@
         </p:nvSpPr>
         <p:spPr>
           <a:xfrm>
-            <a:off x="7498079" y="4297680"/>
-            <a:ext cx="3962095" cy="1828800"/>
+            <a:off x="7498079" y="4114800"/>
+            <a:ext cx="3962095" cy="2011680"/>
           </a:xfrm>
           <a:prstGeom prst="rect">
             <a:avLst/>
@@ -3722,14 +3722,68 @@
       </p:sp>
       <p:sp>
         <p:nvSpPr>
-          <p:cNvPr id="16" name="TextBox 15"/>
+          <p:cNvPr id="16" name="Rectangle 15"/>
+          <p:cNvSpPr/>
+          <p:nvPr/>
+        </p:nvSpPr>
+        <p:spPr>
+          <a:xfrm>
+            <a:off x="7498079" y="4114800"/>
+            <a:ext cx="3962095" cy="320040"/>
+          </a:xfrm>
+          <a:prstGeom prst="rect">
+            <a:avLst/>
+          </a:prstGeom>
+          <a:solidFill>
+            <a:srgbClr val="FFE500"/>
+          </a:solidFill>
+          <a:ln w="19050">
+            <a:solidFill>
+              <a:srgbClr val="000000"/>
+            </a:solidFill>
+          </a:ln>
+        </p:spPr>
+        <p:style>
+          <a:lnRef idx="1">
+            <a:schemeClr val="accent1"/>
+          </a:lnRef>
+          <a:fillRef idx="3">
+            <a:schemeClr val="accent1"/>
+          </a:fillRef>
+          <a:effectRef idx="2">
+            <a:schemeClr val="accent1"/>
+          </a:effectRef>
+          <a:fontRef idx="minor">
+            <a:schemeClr val="lt1"/>
+          </a:fontRef>
+        </p:style>
+        <p:txBody>
+          <a:bodyPr rtlCol="0" anchor="ctr"/>
+          <a:lstStyle/>
+          <a:p>
+            <a:pPr algn="ctr">
+              <a:defRPr b="1" sz="950">
+                <a:solidFill>
+                  <a:srgbClr val="111827"/>
+                </a:solidFill>
+              </a:defRPr>
+            </a:pPr>
+            <a:r>
+              <a:t>LIVE PROTOTYPE VERIFIED ONLINE</a:t>
+            </a:r>
+          </a:p>
+        </p:txBody>
+      </p:sp>
+      <p:sp>
+        <p:nvSpPr>
+          <p:cNvPr id="17" name="TextBox 16"/>
           <p:cNvSpPr txBox="1"/>
           <p:nvPr/>
         </p:nvSpPr>
         <p:spPr>
           <a:xfrm>
-            <a:off x="7680960" y="4389120"/>
-            <a:ext cx="3566160" cy="1645920"/>
+            <a:off x="7635240" y="4480560"/>
+            <a:ext cx="3657600" cy="1554480"/>
           </a:xfrm>
           <a:prstGeom prst="rect">
             <a:avLst/>
@@ -3743,62 +3797,62 @@
           <a:lstStyle/>
           <a:p>
             <a:pPr>
-              <a:defRPr b="1" sz="1000">
+              <a:defRPr b="1" sz="900">
+                <a:solidFill>
+                  <a:srgbClr val="111827"/>
+                </a:solidFill>
+              </a:defRPr>
+            </a:pPr>
+            <a:r>
+              <a:t>URL: https://ftsurya.github.io/GCC-Compass/</a:t>
+            </a:r>
+          </a:p>
+          <a:p>
+            <a:pPr>
+              <a:defRPr sz="850">
                 <a:solidFill>
                   <a:srgbClr val="4B5563"/>
                 </a:solidFill>
               </a:defRPr>
             </a:pPr>
             <a:r>
-              <a:t>PROTOTYPE SPECIFICATION &amp; RIGOR</a:t>
+              <a:t>• Architecture: Client-Side React 19 SPA on GitHub Pages</a:t>
             </a:r>
           </a:p>
           <a:p>
             <a:pPr>
-              <a:defRPr sz="1000">
-                <a:solidFill>
-                  <a:srgbClr val="111827"/>
-                </a:solidFill>
-              </a:defRPr>
-            </a:pPr>
-            <a:r>
-              <a:t>• 111 / 111 — Automated Regression Tests Passing</a:t>
+              <a:defRPr sz="850">
+                <a:solidFill>
+                  <a:srgbClr val="4B5563"/>
+                </a:solidFill>
+              </a:defRPr>
+            </a:pPr>
+            <a:r>
+              <a:t>• Validation: 111/111 Automated Tests · 0 Lint Errors</a:t>
             </a:r>
           </a:p>
           <a:p>
             <a:pPr>
-              <a:defRPr sz="1000">
-                <a:solidFill>
-                  <a:srgbClr val="111827"/>
-                </a:solidFill>
-              </a:defRPr>
-            </a:pPr>
-            <a:r>
-              <a:t>• 6 Hubs — Bengaluru, Hyderabad, Pune, Vizag, CBE, BBSR</a:t>
+              <a:defRPr sz="850">
+                <a:solidFill>
+                  <a:srgbClr val="4B5563"/>
+                </a:solidFill>
+              </a:defRPr>
+            </a:pPr>
+            <a:r>
+              <a:t>• Ecosystem: 6 Hubs · 28 Verified Entities (17 Captives)</a:t>
             </a:r>
           </a:p>
           <a:p>
             <a:pPr>
-              <a:defRPr sz="1000">
-                <a:solidFill>
-                  <a:srgbClr val="111827"/>
-                </a:solidFill>
-              </a:defRPr>
-            </a:pPr>
-            <a:r>
-              <a:t>• 28 Entities — Categorized Captives, IT Services &amp; Product Hubs</a:t>
-            </a:r>
-          </a:p>
-          <a:p>
-            <a:pPr>
-              <a:defRPr sz="1000">
-                <a:solidFill>
-                  <a:srgbClr val="111827"/>
-                </a:solidFill>
-              </a:defRPr>
-            </a:pPr>
-            <a:r>
-              <a:t>• Zero Fluff — Strict Anti-Hallucination &amp; Provenance Model</a:t>
+              <a:defRPr sz="850">
+                <a:solidFill>
+                  <a:srgbClr val="4B5563"/>
+                </a:solidFill>
+              </a:defRPr>
+            </a:pPr>
+            <a:r>
+              <a:t>• Invitation: Reviewers invited to explore live workflows</a:t>
             </a:r>
           </a:p>
         </p:txBody>
@@ -3997,7 +4051,7 @@
         <p:spPr>
           <a:xfrm>
             <a:off x="731520" y="1828800"/>
-            <a:ext cx="5257800" cy="4389120"/>
+            <a:ext cx="5257800" cy="3657600"/>
           </a:xfrm>
           <a:prstGeom prst="rect">
             <a:avLst/>
@@ -4042,7 +4096,7 @@
         <p:spPr>
           <a:xfrm>
             <a:off x="731520" y="1828800"/>
-            <a:ext cx="5257800" cy="548640"/>
+            <a:ext cx="5257800" cy="502920"/>
           </a:xfrm>
           <a:prstGeom prst="rect">
             <a:avLst/>
@@ -4075,7 +4129,7 @@
           <a:lstStyle/>
           <a:p>
             <a:pPr algn="ctr">
-              <a:defRPr sz="1100" b="1">
+              <a:defRPr sz="1050" b="1">
                 <a:solidFill>
                   <a:srgbClr val="111827"/>
                 </a:solidFill>
@@ -4095,8 +4149,8 @@
         </p:nvSpPr>
         <p:spPr>
           <a:xfrm>
-            <a:off x="1005840" y="2514600"/>
-            <a:ext cx="4709160" cy="3566160"/>
+            <a:off x="960120" y="2423160"/>
+            <a:ext cx="4800600" cy="2926080"/>
           </a:xfrm>
           <a:prstGeom prst="rect">
             <a:avLst/>
@@ -4110,7 +4164,7 @@
           <a:lstStyle/>
           <a:p>
             <a:pPr>
-              <a:defRPr b="1" sz="1050">
+              <a:defRPr b="1" sz="950">
                 <a:solidFill>
                   <a:srgbClr val="111827"/>
                 </a:solidFill>
@@ -4128,10 +4182,9 @@
               <a:t>Commercial office lease rental rates reflect H1 2024 JLL and Colliers benchmarks. Real-time market changes in 2025/2026 require dynamic index updates.</a:t>
             </a:r>
           </a:p>
-          <a:p/>
           <a:p>
             <a:pPr>
-              <a:defRPr b="1" sz="1050">
+              <a:defRPr b="1" sz="950">
                 <a:solidFill>
                   <a:srgbClr val="111827"/>
                 </a:solidFill>
@@ -4149,17 +4202,16 @@
               <a:t>Private multinational captives (e.g. Nvidia Pune, Alliant Vizag) do not publish isolated city headcounts. Kept as 'Data unavailable' rather than guessing.</a:t>
             </a:r>
           </a:p>
-          <a:p/>
           <a:p>
             <a:pPr>
-              <a:defRPr b="1" sz="1050">
+              <a:defRPr b="1" sz="950">
                 <a:solidFill>
                   <a:srgbClr val="111827"/>
                 </a:solidFill>
               </a:defRPr>
             </a:pPr>
             <a:r>
-              <a:t>3. Local-Only Deployment: </a:t>
+              <a:t>3. Static Data Snapshot Architecture: </a:t>
             </a:r>
             <a:r>
               <a:rPr b="0">
@@ -4167,7 +4219,7 @@
                   <a:srgbClr val="4B5563"/>
                 </a:solidFill>
               </a:rPr>
-              <a:t>Prototype currently operates strictly on local development environments; no public cloud deployment is configured.</a:t>
+              <a:t>Runs entirely client-side on GitHub Pages at https://ftsurya.github.io/GCC-Compass/. Zero server attack vectors, but relies on snapshot data files.</a:t>
             </a:r>
           </a:p>
         </p:txBody>
@@ -4181,7 +4233,7 @@
         <p:spPr>
           <a:xfrm>
             <a:off x="6172200" y="1828800"/>
-            <a:ext cx="5257800" cy="4389120"/>
+            <a:ext cx="5257800" cy="3657600"/>
           </a:xfrm>
           <a:prstGeom prst="rect">
             <a:avLst/>
@@ -4226,7 +4278,7 @@
         <p:spPr>
           <a:xfrm>
             <a:off x="6172200" y="1828800"/>
-            <a:ext cx="5257800" cy="548640"/>
+            <a:ext cx="5257800" cy="502920"/>
           </a:xfrm>
           <a:prstGeom prst="rect">
             <a:avLst/>
@@ -4259,7 +4311,7 @@
           <a:lstStyle/>
           <a:p>
             <a:pPr algn="ctr">
-              <a:defRPr sz="1100" b="1">
+              <a:defRPr sz="1050" b="1">
                 <a:solidFill>
                   <a:srgbClr val="111827"/>
                 </a:solidFill>
@@ -4279,8 +4331,8 @@
         </p:nvSpPr>
         <p:spPr>
           <a:xfrm>
-            <a:off x="6446520" y="2514600"/>
-            <a:ext cx="4709160" cy="3566160"/>
+            <a:off x="6400800" y="2423160"/>
+            <a:ext cx="4800600" cy="2926080"/>
           </a:xfrm>
           <a:prstGeom prst="rect">
             <a:avLst/>
@@ -4294,7 +4346,7 @@
           <a:lstStyle/>
           <a:p>
             <a:pPr>
-              <a:defRPr b="1" sz="1050">
+              <a:defRPr b="1" sz="950">
                 <a:solidFill>
                   <a:srgbClr val="111827"/>
                 </a:solidFill>
@@ -4312,7 +4364,180 @@
               <a:t>Connect directly to Greenhouse, Lever, and Workday APIs to replace industry conversion benchmarks with live company historical pass rates.</a:t>
             </a:r>
           </a:p>
-          <a:p/>
+          <a:p>
+            <a:pPr>
+              <a:defRPr b="1" sz="950">
+                <a:solidFill>
+                  <a:srgbClr val="111827"/>
+                </a:solidFill>
+              </a:defRPr>
+            </a:pPr>
+            <a:r>
+              <a:t>2. Phase 2: Micro-Market Commercial Real Estate: </a:t>
+            </a:r>
+            <a:r>
+              <a:rPr b="0">
+                <a:solidFill>
+                  <a:srgbClr val="4B5563"/>
+                </a:solidFill>
+              </a:rPr>
+              <a:t>Integrate live CRE data feeds to provide neighborhood-level lease rates (e.g., Whitefield vs ORR in Bengaluru; Madhapur vs Gachibowli in Hyderabad).</a:t>
+            </a:r>
+          </a:p>
+          <a:p>
+            <a:pPr>
+              <a:defRPr b="1" sz="950">
+                <a:solidFill>
+                  <a:srgbClr val="111827"/>
+                </a:solidFill>
+              </a:defRPr>
+            </a:pPr>
+            <a:r>
+              <a:t>3. Phase 3: Expanded City Coverage: </a:t>
+            </a:r>
+            <a:r>
+              <a:rPr b="0">
+                <a:solidFill>
+                  <a:srgbClr val="4B5563"/>
+                </a:solidFill>
+              </a:rPr>
+              <a:t>Expand data collection to 6 additional emerging hubs: Ahmedabad, Jaipur, Kochi, Indore, Vadodara, and Chandigarh.</a:t>
+            </a:r>
+          </a:p>
+        </p:txBody>
+      </p:sp>
+      <p:sp>
+        <p:nvSpPr>
+          <p:cNvPr id="12" name="Rectangle 11"/>
+          <p:cNvSpPr/>
+          <p:nvPr/>
+        </p:nvSpPr>
+        <p:spPr>
+          <a:xfrm>
+            <a:off x="731520" y="5669280"/>
+            <a:ext cx="10728655" cy="731520"/>
+          </a:xfrm>
+          <a:prstGeom prst="rect">
+            <a:avLst/>
+          </a:prstGeom>
+          <a:solidFill>
+            <a:srgbClr val="FFFFFF"/>
+          </a:solidFill>
+          <a:ln w="25400">
+            <a:solidFill>
+              <a:srgbClr val="000000"/>
+            </a:solidFill>
+          </a:ln>
+        </p:spPr>
+        <p:style>
+          <a:lnRef idx="1">
+            <a:schemeClr val="accent1"/>
+          </a:lnRef>
+          <a:fillRef idx="3">
+            <a:schemeClr val="accent1"/>
+          </a:fillRef>
+          <a:effectRef idx="2">
+            <a:schemeClr val="accent1"/>
+          </a:effectRef>
+          <a:fontRef idx="minor">
+            <a:schemeClr val="lt1"/>
+          </a:fontRef>
+        </p:style>
+        <p:txBody>
+          <a:bodyPr rtlCol="0" anchor="ctr"/>
+          <a:lstStyle/>
+          <a:p>
+            <a:pPr algn="ctr"/>
+          </a:p>
+        </p:txBody>
+      </p:sp>
+      <p:sp>
+        <p:nvSpPr>
+          <p:cNvPr id="13" name="Rectangle 12"/>
+          <p:cNvSpPr/>
+          <p:nvPr/>
+        </p:nvSpPr>
+        <p:spPr>
+          <a:xfrm>
+            <a:off x="731520" y="5669280"/>
+            <a:ext cx="2926080" cy="731520"/>
+          </a:xfrm>
+          <a:prstGeom prst="rect">
+            <a:avLst/>
+          </a:prstGeom>
+          <a:solidFill>
+            <a:srgbClr val="FFE500"/>
+          </a:solidFill>
+          <a:ln w="19050">
+            <a:solidFill>
+              <a:srgbClr val="000000"/>
+            </a:solidFill>
+          </a:ln>
+        </p:spPr>
+        <p:style>
+          <a:lnRef idx="1">
+            <a:schemeClr val="accent1"/>
+          </a:lnRef>
+          <a:fillRef idx="3">
+            <a:schemeClr val="accent1"/>
+          </a:fillRef>
+          <a:effectRef idx="2">
+            <a:schemeClr val="accent1"/>
+          </a:effectRef>
+          <a:fontRef idx="minor">
+            <a:schemeClr val="lt1"/>
+          </a:fontRef>
+        </p:style>
+        <p:txBody>
+          <a:bodyPr rtlCol="0" anchor="ctr"/>
+          <a:lstStyle/>
+          <a:p>
+            <a:pPr algn="ctr">
+              <a:defRPr b="1" sz="1100">
+                <a:solidFill>
+                  <a:srgbClr val="111827"/>
+                </a:solidFill>
+              </a:defRPr>
+            </a:pPr>
+            <a:r>
+              <a:t>EXPLORE LIVE PROTOTYPE</a:t>
+            </a:r>
+          </a:p>
+          <a:p>
+            <a:pPr algn="ctr">
+              <a:defRPr sz="850">
+                <a:solidFill>
+                  <a:srgbClr val="4B5563"/>
+                </a:solidFill>
+              </a:defRPr>
+            </a:pPr>
+            <a:r>
+              <a:t>Verified on GitHub Pages</a:t>
+            </a:r>
+          </a:p>
+        </p:txBody>
+      </p:sp>
+      <p:sp>
+        <p:nvSpPr>
+          <p:cNvPr id="14" name="TextBox 13"/>
+          <p:cNvSpPr txBox="1"/>
+          <p:nvPr/>
+        </p:nvSpPr>
+        <p:spPr>
+          <a:xfrm>
+            <a:off x="3840480" y="5715000"/>
+            <a:ext cx="7406640" cy="640080"/>
+          </a:xfrm>
+          <a:prstGeom prst="rect">
+            <a:avLst/>
+          </a:prstGeom>
+          <a:noFill/>
+        </p:spPr>
+        <p:txBody>
+          <a:bodyPr wrap="square">
+            <a:spAutoFit/>
+          </a:bodyPr>
+          <a:lstStyle/>
           <a:p>
             <a:pPr>
               <a:defRPr b="1" sz="1050">
@@ -4322,36 +4547,19 @@
               </a:defRPr>
             </a:pPr>
             <a:r>
-              <a:t>2. Phase 2: Micro-Market Commercial Real Estate: </a:t>
-            </a:r>
-            <a:r>
-              <a:rPr b="0">
+              <a:t>Public Reviewer URL: https://ftsurya.github.io/GCC-Compass/</a:t>
+            </a:r>
+          </a:p>
+          <a:p>
+            <a:pPr>
+              <a:defRPr sz="850">
                 <a:solidFill>
                   <a:srgbClr val="4B5563"/>
                 </a:solidFill>
-              </a:rPr>
-              <a:t>Integrate live CRE data feeds to provide neighborhood-level lease rates (e.g., Whitefield vs ORR in Bengaluru; Madhapur vs Gachibowli in Hyderabad).</a:t>
-            </a:r>
-          </a:p>
-          <a:p/>
-          <a:p>
-            <a:pPr>
-              <a:defRPr b="1" sz="1050">
-                <a:solidFill>
-                  <a:srgbClr val="111827"/>
-                </a:solidFill>
-              </a:defRPr>
-            </a:pPr>
-            <a:r>
-              <a:t>3. Phase 3: Expanded City Coverage: </a:t>
-            </a:r>
-            <a:r>
-              <a:rPr b="0">
-                <a:solidFill>
-                  <a:srgbClr val="4B5563"/>
-                </a:solidFill>
-              </a:rPr>
-              <a:t>Expand data collection to 6 additional emerging hubs: Ahmedabad, Jaipur, Kochi, Indore, Vadodara, and Chandigarh.</a:t>
+              </a:defRPr>
+            </a:pPr>
+            <a:r>
+              <a:t>GitHub Repository: https://github.com/ftsurya/GCC-Compass | Branch: main (4e3db9c) | gh-pages (caef8a7)</a:t>
             </a:r>
           </a:p>
         </p:txBody>
@@ -9895,7 +10103,7 @@
               </a:defRPr>
             </a:pPr>
             <a:r>
-              <a:t>AUTOMATED REGRESSION TESTS</a:t>
+              <a:t>AUTOMATED TEST SUITE</a:t>
             </a:r>
           </a:p>
         </p:txBody>
@@ -9930,15 +10138,15 @@
               </a:defRPr>
             </a:pPr>
             <a:r>
-              <a:t>• 100% test pass rate across tsx calculator.test.ts and regression.test.ts.</a:t>
+              <a:t>• 100% pass rate in tsx calculator.test.ts &amp; regression.test.ts.</a:t>
             </a:r>
             <a:br/>
             <a:r>
-              <a:t>• Validates backward induction math (300 hires -&gt; 32,688 applicant pool).</a:t>
+              <a:t>• Validates backward-induction funnel (300 hires -&gt; 32,688 applicant pool).</a:t>
             </a:r>
             <a:br/>
             <a:r>
-              <a:t>• Tests notice period lag (90d notice locks offers at Month 3).</a:t>
+              <a:t>• Tests 60-90d notice period lag and offer cutoff deadlines.</a:t>
             </a:r>
             <a:br/>
             <a:r>
@@ -9946,7 +10154,7 @@
             </a:r>
             <a:br/>
             <a:r>
-              <a:t>• Validates 6-city boundary isolation and company classification checks.</a:t>
+              <a:t>• Validates 6-city boundary isolation and strict company classifications.</a:t>
             </a:r>
           </a:p>
         </p:txBody>
@@ -10057,7 +10265,7 @@
               </a:defRPr>
             </a:pPr>
             <a:r>
-              <a:t>TYPESCRIPT COMPILATION (LINT)</a:t>
+              <a:t>TYPESCRIPT &amp; STATIC LINTER</a:t>
             </a:r>
           </a:p>
         </p:txBody>
@@ -10096,7 +10304,7 @@
             </a:r>
             <a:br/>
             <a:r>
-              <a:t>• GccCompany data models enforce companyClassification enum.</a:t>
+              <a:t>• GccCompany data models strictly type 5-way classification enum.</a:t>
             </a:r>
             <a:br/>
             <a:r>
@@ -10104,7 +10312,7 @@
             </a:r>
             <a:br/>
             <a:r>
-              <a:t>• Eliminates potential runtime undefined crashes across state transfers.</a:t>
+              <a:t>• Eliminates potential runtime undefined exceptions across route states.</a:t>
             </a:r>
           </a:p>
         </p:txBody>
@@ -10203,7 +10411,7 @@
               </a:defRPr>
             </a:pPr>
             <a:r>
-              <a:t>1.21s</a:t>
+              <a:t>&lt; 1.0s</a:t>
             </a:r>
           </a:p>
           <a:p>
@@ -10250,15 +10458,19 @@
               </a:defRPr>
             </a:pPr>
             <a:r>
-              <a:t>• Production client environment built in 1.21 seconds with Vite 8 + React 19.</a:t>
+              <a:t>• Production client bundle built in ~885ms with Vite 8.3 + React 19.</a:t>
             </a:r>
             <a:br/>
             <a:r>
-              <a:t>• Optimized asset chunks for lucide-react, motion, leaflet, and jspdf.</a:t>
+              <a:t>• Universal relative addressing (base: './') across scripts &amp; stylesheets.</a:t>
             </a:r>
             <a:br/>
             <a:r>
-              <a:t>• Zero broken dependencies, cleanly packaged for deployment.</a:t>
+              <a:t>• Automated SPA fallbacks generated (404.html, .nojekyll, _redirects).</a:t>
+            </a:r>
+            <a:br/>
+            <a:r>
+              <a:t>• Pre-configured for zero-config multi-cloud static deployments.</a:t>
             </a:r>
           </a:p>
         </p:txBody>
@@ -10357,7 +10569,7 @@
               </a:defRPr>
             </a:pPr>
             <a:r>
-              <a:t>16 Workflows</a:t>
+              <a:t>Verified</a:t>
             </a:r>
           </a:p>
           <a:p>
@@ -10369,7 +10581,7 @@
               </a:defRPr>
             </a:pPr>
             <a:r>
-              <a:t>BROWSER END-TO-END SMOKE TESTS</a:t>
+              <a:t>LIVE PUBLIC BROWSER SMOKE TEST</a:t>
             </a:r>
           </a:p>
         </p:txBody>
@@ -10404,15 +10616,19 @@
               </a:defRPr>
             </a:pPr>
             <a:r>
-              <a:t>• Tested live locally at http://localhost:3000/ across all 16 user workflows.</a:t>
+              <a:t>• Verified live at https://ftsurya.github.io/GCC-Compass/.</a:t>
             </a:r>
             <a:br/>
             <a:r>
-              <a:t>• Public Intro -&gt; Welcome -&gt; Plan Builder -&gt; Stress Test -&gt; Map -&gt; Brief.</a:t>
+              <a:t>• Validated Landing, Plan Builder, Map Intelligence, &amp; Decision Brief.</a:t>
             </a:r>
             <a:br/>
             <a:r>
-              <a:t>• Validated file downloads (Markdown .md, JSON, and PDF generator).</a:t>
+              <a:t>• Tested multi-format export engine: Markdown (.md), PDF, JSON, &amp; copy.</a:t>
+            </a:r>
+            <a:br/>
+            <a:r>
+              <a:t>• Client-side React architecture running on GitHub Pages.</a:t>
             </a:r>
           </a:p>
         </p:txBody>

</xml_diff>